<commit_message>
Focus genetics presentation on one research paper and expand its discussion
</commit_message>
<xml_diff>
--- a/Eugenics_Genetics_Presentation.pptx
+++ b/Eugenics_Genetics_Presentation.pptx
@@ -516,7 +516,7 @@
           <a:lstStyle/>
           <a:p>
             <a:r>
-              <a:t>This presentation follows the required sections from introduction to references. The topic is discussed through two research papers on polygenic embryo selection. No calendar date or time is displayed.</a:t>
+              <a:t>This presentation follows the required sections from introduction to references and discusses one research paper on polygenic embryo screening. No calendar date or time is displayed.</a:t>
             </a:r>
           </a:p>
         </p:txBody>
@@ -936,7 +936,7 @@
           <a:lstStyle/>
           <a:p>
             <a:r>
-              <a:t>The two main research papers are references 1 and 2. The full text of reference 2 was inspected in eLife’s official publication archive. Reference 1 was corroborated using the authors’ code repository and its discussion in reference 2. Other sources provide background and clinical or ethical guidance. Some original websites were blocked by the environment, as disclosed in the earlier report. Bibliographic years and cover dates are omitted to follow the request for no dates or times.</a:t>
+              <a:t>The one selected research paper is reference 1. Its full text was inspected in eLife’s official publication archive. The other references are supporting clinical, historical, and human-rights sources. Some supporting websites could not be directly retrieved. Bibliographic years and cover dates are omitted as requested.</a:t>
             </a:r>
           </a:p>
         </p:txBody>
@@ -1356,7 +1356,7 @@
           <a:lstStyle/>
           <a:p>
             <a:r>
-              <a:t>A polygenic score combines many genetic associations. This paper evaluated quantitative traits through modelling and empirical family analyses. Its conclusions should not automatically be extended to all future scores, every disease, or every IVF situation. The title and modelling purpose were corroborated in the authors’ research repository and the second paper.</a:t>
+              <a:t>This is the only research paper discussed in this presentation. The full text was read in the publisher’s official XML archive. Virtual offspring were simulated from real genomes; the study did not follow children born after screening. It used a liability-threshold model to estimate disease risk.</a:t>
             </a:r>
           </a:p>
         </p:txBody>
@@ -1426,7 +1426,7 @@
           <a:lstStyle/>
           <a:p>
             <a:r>
-              <a:t>The full text was inspected in eLife’s official XML archive. Excluding high-risk embryos gave relatively modest reductions, while prioritizing the lowest-risk embryo could yield substantial relative reductions under assumptions. The real-data analysis simulated offspring from case-control genomes; it did not follow children born after screening. The model considered one target disease at a time.</a:t>
+              <a:t>The paper found that the high-risk exclusion strategy was relatively ineffective compared with lowest-risk prioritization. Some model scenarios gave substantial relative reductions. Absolute reductions and benefits for a particular couple varied. These predictions depend on the model’s assumptions and are not a clinical guarantee.</a:t>
             </a:r>
           </a:p>
         </p:txBody>
@@ -1496,7 +1496,7 @@
           <a:lstStyle/>
           <a:p>
             <a:r>
-              <a:t>The numbers in the example are invented only to explain absolute and relative risk. They are not a result from either paper. Different findings are compatible because selecting for a quantitative trait and reducing disease risk involve different outcomes.</a:t>
+              <a:t>The paper discusses the limits of transferring scores between populations and from unrelated people to comparisons within a family. It assumes viable embryos rather than simply counting fertilized eggs. It also calls for discussion of ethical concerns. Scientific evidence informs the eugenics debate but cannot decide consent, equality, or human worth.</a:t>
             </a:r>
           </a:p>
         </p:txBody>
@@ -5352,7 +5352,7 @@
                 </a:solidFill>
                 <a:latin typeface="Liberation Sans"/>
               </a:rPr>
-              <a:t>Sources: [1], [2], [4]</a:t>
+              <a:t>Sources: [1], [3]</a:t>
             </a:r>
           </a:p>
         </p:txBody>
@@ -5968,7 +5968,7 @@
                 </a:solidFill>
                 <a:latin typeface="Liberation Sans"/>
               </a:rPr>
-              <a:t>Sources: [4], [5], [7]</a:t>
+              <a:t>Sources: [3], [4], [6]</a:t>
             </a:r>
           </a:p>
         </p:txBody>
@@ -6877,7 +6877,7 @@
                 </a:solidFill>
                 <a:latin typeface="Liberation Sans"/>
               </a:rPr>
-              <a:t>Sources: [4], [5], [7]</a:t>
+              <a:t>Sources: [3], [4], [6]</a:t>
             </a:r>
           </a:p>
         </p:txBody>
@@ -8174,7 +8174,7 @@
                 </a:solidFill>
                 <a:latin typeface="Liberation Sans"/>
               </a:rPr>
-              <a:t>Sources: [1], [2], [5]</a:t>
+              <a:t>Sources: [1], [4]</a:t>
             </a:r>
           </a:p>
         </p:txBody>
@@ -9083,7 +9083,7 @@
                 </a:solidFill>
                 <a:latin typeface="Liberation Sans"/>
               </a:rPr>
-              <a:t>Sources: [1], [2], [7]</a:t>
+              <a:t>Sources: [1], [6]</a:t>
             </a:r>
           </a:p>
         </p:txBody>
@@ -9617,7 +9617,7 @@
                 </a:solidFill>
                 <a:latin typeface="Liberation Sans"/>
               </a:rPr>
-              <a:t>Two research papers and supporting sources</a:t>
+              <a:t>One research paper and supporting sources</a:t>
             </a:r>
           </a:p>
         </p:txBody>
@@ -9821,7 +9821,7 @@
                 </a:solidFill>
                 <a:latin typeface="Liberation Sans"/>
               </a:rPr>
-              <a:t>[1] Karavani, E., Zuk, O., Zeevi, D., et al. Screening human embryos for polygenic traits has limited utility. Cell, 179(6), 1424–1435.e8.</a:t>
+              <a:t>[1] Lencz, T., Backenroth, D., Granot-Hershkovitz, E., et al. Utility of polygenic embryo screening for disease depends on the selection strategy. eLife, 10, e64716.</a:t>
             </a:r>
           </a:p>
         </p:txBody>
@@ -9864,7 +9864,7 @@
                 <a:latin typeface="Liberation Sans"/>
                 <a:hlinkClick r:id="rId2"/>
               </a:rPr>
-              <a:t>DOI: 10.1016/j.cell.2019.10.033</a:t>
+              <a:t>DOI: 10.7554/eLife.64716</a:t>
             </a:r>
           </a:p>
         </p:txBody>
@@ -9878,7 +9878,7 @@
         <p:spPr>
           <a:xfrm>
             <a:off x="777240" y="2372868"/>
-            <a:ext cx="10607040" cy="557784"/>
+            <a:ext cx="10607040" cy="301752"/>
           </a:xfrm>
           <a:prstGeom prst="rect">
             <a:avLst/>
@@ -9893,20 +9893,20 @@
           <a:p>
             <a:pPr algn="l">
               <a:lnSpc>
-                <a:spcPts val="1829"/>
-              </a:lnSpc>
-              <a:spcAft>
-                <a:spcPts val="800"/>
-              </a:spcAft>
-            </a:pPr>
-            <a:r>
-              <a:rPr sz="1550" b="0">
+                <a:spcPts val="1817"/>
+              </a:lnSpc>
+              <a:spcAft>
+                <a:spcPts val="800"/>
+              </a:spcAft>
+            </a:pPr>
+            <a:r>
+              <a:rPr sz="1540" b="0">
                 <a:solidFill>
                   <a:srgbClr val="24312E"/>
                 </a:solidFill>
                 <a:latin typeface="Liberation Sans"/>
               </a:rPr>
-              <a:t>[2] Lencz, T., Backenroth, D., Granot-Hershkovitz, E., et al. Utility of polygenic embryo screening for disease depends on the selection strategy. eLife, 10, e64716.</a:t>
+              <a:t>[2] GeneReviews®. HEXA Disorders. NCBI Bookshelf.</a:t>
             </a:r>
           </a:p>
         </p:txBody>
@@ -9919,7 +9919,7 @@
         </p:nvSpPr>
         <p:spPr>
           <a:xfrm>
-            <a:off x="777240" y="2953512"/>
+            <a:off x="777240" y="2706624"/>
             <a:ext cx="10607040" cy="219456"/>
           </a:xfrm>
           <a:prstGeom prst="rect">
@@ -9949,7 +9949,7 @@
                 <a:latin typeface="Liberation Sans"/>
                 <a:hlinkClick r:id="rId3"/>
               </a:rPr>
-              <a:t>DOI: 10.7554/eLife.64716</a:t>
+              <a:t>Open source</a:t>
             </a:r>
           </a:p>
         </p:txBody>
@@ -9962,8 +9962,8 @@
         </p:nvSpPr>
         <p:spPr>
           <a:xfrm>
-            <a:off x="640080" y="3296412"/>
-            <a:ext cx="10917936" cy="548640"/>
+            <a:off x="640080" y="3031236"/>
+            <a:ext cx="10917936" cy="667512"/>
           </a:xfrm>
           <a:prstGeom prst="rect">
             <a:avLst/>
@@ -10005,8 +10005,8 @@
         </p:nvSpPr>
         <p:spPr>
           <a:xfrm>
-            <a:off x="777240" y="3360420"/>
-            <a:ext cx="10607040" cy="265176"/>
+            <a:off x="777240" y="3095244"/>
+            <a:ext cx="10607040" cy="301752"/>
           </a:xfrm>
           <a:prstGeom prst="rect">
             <a:avLst/>
@@ -10034,7 +10034,7 @@
                 </a:solidFill>
                 <a:latin typeface="Liberation Sans"/>
               </a:rPr>
-              <a:t>[3] GeneReviews®. HEXA Disorders. NCBI Bookshelf.</a:t>
+              <a:t>[3] Human Fertilisation and Embryology Authority. PGT-M and PGT-SR: patient information.</a:t>
             </a:r>
           </a:p>
         </p:txBody>
@@ -10047,7 +10047,7 @@
         </p:nvSpPr>
         <p:spPr>
           <a:xfrm>
-            <a:off x="777240" y="3634740"/>
+            <a:off x="777240" y="3429000"/>
             <a:ext cx="10607040" cy="219456"/>
           </a:xfrm>
           <a:prstGeom prst="rect">
@@ -10090,8 +10090,8 @@
         </p:nvSpPr>
         <p:spPr>
           <a:xfrm>
-            <a:off x="777240" y="3963924"/>
-            <a:ext cx="10607040" cy="265176"/>
+            <a:off x="777240" y="3817620"/>
+            <a:ext cx="10607040" cy="301752"/>
           </a:xfrm>
           <a:prstGeom prst="rect">
             <a:avLst/>
@@ -10119,7 +10119,7 @@
                 </a:solidFill>
                 <a:latin typeface="Liberation Sans"/>
               </a:rPr>
-              <a:t>[4] Human Fertilisation and Embryology Authority. PGT-M and PGT-SR: patient information.</a:t>
+              <a:t>[4] World Health Organization. Human Genome Editing: Recommendations.</a:t>
             </a:r>
           </a:p>
         </p:txBody>
@@ -10132,7 +10132,7 @@
         </p:nvSpPr>
         <p:spPr>
           <a:xfrm>
-            <a:off x="777240" y="4238244"/>
+            <a:off x="777240" y="4151376"/>
             <a:ext cx="10607040" cy="219456"/>
           </a:xfrm>
           <a:prstGeom prst="rect">
@@ -10175,8 +10175,8 @@
         </p:nvSpPr>
         <p:spPr>
           <a:xfrm>
-            <a:off x="640080" y="4503420"/>
-            <a:ext cx="10917936" cy="548640"/>
+            <a:off x="640080" y="4475988"/>
+            <a:ext cx="10917936" cy="667512"/>
           </a:xfrm>
           <a:prstGeom prst="rect">
             <a:avLst/>
@@ -10218,8 +10218,8 @@
         </p:nvSpPr>
         <p:spPr>
           <a:xfrm>
-            <a:off x="777240" y="4567428"/>
-            <a:ext cx="10607040" cy="265176"/>
+            <a:off x="777240" y="4539996"/>
+            <a:ext cx="10607040" cy="301752"/>
           </a:xfrm>
           <a:prstGeom prst="rect">
             <a:avLst/>
@@ -10247,7 +10247,7 @@
                 </a:solidFill>
                 <a:latin typeface="Liberation Sans"/>
               </a:rPr>
-              <a:t>[5] World Health Organization. Human Genome Editing: Recommendations.</a:t>
+              <a:t>[5] United States Holocaust Memorial Museum. Eugenics. Holocaust Encyclopedia.</a:t>
             </a:r>
           </a:p>
         </p:txBody>
@@ -10260,7 +10260,7 @@
         </p:nvSpPr>
         <p:spPr>
           <a:xfrm>
-            <a:off x="777240" y="4841748"/>
+            <a:off x="777240" y="4873752"/>
             <a:ext cx="10607040" cy="219456"/>
           </a:xfrm>
           <a:prstGeom prst="rect">
@@ -10303,8 +10303,8 @@
         </p:nvSpPr>
         <p:spPr>
           <a:xfrm>
-            <a:off x="777240" y="5170932"/>
-            <a:ext cx="10607040" cy="265176"/>
+            <a:off x="777240" y="5262372"/>
+            <a:ext cx="10607040" cy="301752"/>
           </a:xfrm>
           <a:prstGeom prst="rect">
             <a:avLst/>
@@ -10332,7 +10332,7 @@
                 </a:solidFill>
                 <a:latin typeface="Liberation Sans"/>
               </a:rPr>
-              <a:t>[6] United States Holocaust Memorial Museum. Eugenics. Holocaust Encyclopedia.</a:t>
+              <a:t>[6] United Nations. Convention on the Rights of Persons with Disabilities, Article 23.</a:t>
             </a:r>
           </a:p>
         </p:txBody>
@@ -10345,7 +10345,7 @@
         </p:nvSpPr>
         <p:spPr>
           <a:xfrm>
-            <a:off x="777240" y="5445252"/>
+            <a:off x="777240" y="5596128"/>
             <a:ext cx="10607040" cy="219456"/>
           </a:xfrm>
           <a:prstGeom prst="rect">
@@ -10374,134 +10374,6 @@
                 </a:solidFill>
                 <a:latin typeface="Liberation Sans"/>
                 <a:hlinkClick r:id="rId7"/>
-              </a:rPr>
-              <a:t>Open source</a:t>
-            </a:r>
-          </a:p>
-        </p:txBody>
-      </p:sp>
-      <p:sp>
-        <p:nvSpPr>
-          <p:cNvPr id="23" name="Rectangle 22"/>
-          <p:cNvSpPr/>
-          <p:nvPr/>
-        </p:nvSpPr>
-        <p:spPr>
-          <a:xfrm>
-            <a:off x="640080" y="5710428"/>
-            <a:ext cx="10917936" cy="548640"/>
-          </a:xfrm>
-          <a:prstGeom prst="rect">
-            <a:avLst/>
-          </a:prstGeom>
-          <a:solidFill>
-            <a:srgbClr val="EEF5F1"/>
-          </a:solidFill>
-          <a:ln>
-            <a:noFill/>
-          </a:ln>
-        </p:spPr>
-        <p:style>
-          <a:lnRef idx="1">
-            <a:schemeClr val="accent1"/>
-          </a:lnRef>
-          <a:fillRef idx="3">
-            <a:schemeClr val="accent1"/>
-          </a:fillRef>
-          <a:effectRef idx="0">
-            <a:schemeClr val="accent1"/>
-          </a:effectRef>
-          <a:fontRef idx="minor">
-            <a:schemeClr val="lt1"/>
-          </a:fontRef>
-        </p:style>
-        <p:txBody>
-          <a:bodyPr rtlCol="0" anchor="ctr"/>
-          <a:lstStyle/>
-          <a:p>
-            <a:pPr algn="ctr"/>
-          </a:p>
-        </p:txBody>
-      </p:sp>
-      <p:sp>
-        <p:nvSpPr>
-          <p:cNvPr id="24" name="TextBox 23"/>
-          <p:cNvSpPr txBox="1"/>
-          <p:nvPr/>
-        </p:nvSpPr>
-        <p:spPr>
-          <a:xfrm>
-            <a:off x="777240" y="5774436"/>
-            <a:ext cx="10607040" cy="265176"/>
-          </a:xfrm>
-          <a:prstGeom prst="rect">
-            <a:avLst/>
-          </a:prstGeom>
-          <a:noFill/>
-        </p:spPr>
-        <p:txBody>
-          <a:bodyPr wrap="square" lIns="0" rIns="0" tIns="0" bIns="0" anchor="t">
-            <a:spAutoFit/>
-          </a:bodyPr>
-          <a:lstStyle/>
-          <a:p>
-            <a:pPr algn="l">
-              <a:lnSpc>
-                <a:spcPts val="1817"/>
-              </a:lnSpc>
-              <a:spcAft>
-                <a:spcPts val="800"/>
-              </a:spcAft>
-            </a:pPr>
-            <a:r>
-              <a:rPr sz="1540" b="0">
-                <a:solidFill>
-                  <a:srgbClr val="24312E"/>
-                </a:solidFill>
-                <a:latin typeface="Liberation Sans"/>
-              </a:rPr>
-              <a:t>[7] United Nations. Convention on the Rights of Persons with Disabilities, Article 23.</a:t>
-            </a:r>
-          </a:p>
-        </p:txBody>
-      </p:sp>
-      <p:sp>
-        <p:nvSpPr>
-          <p:cNvPr id="25" name="TextBox 24"/>
-          <p:cNvSpPr txBox="1"/>
-          <p:nvPr/>
-        </p:nvSpPr>
-        <p:spPr>
-          <a:xfrm>
-            <a:off x="777240" y="6048756"/>
-            <a:ext cx="10607040" cy="219456"/>
-          </a:xfrm>
-          <a:prstGeom prst="rect">
-            <a:avLst/>
-          </a:prstGeom>
-          <a:noFill/>
-        </p:spPr>
-        <p:txBody>
-          <a:bodyPr wrap="square" lIns="0" rIns="0" tIns="0" bIns="0" anchor="t">
-            <a:spAutoFit/>
-          </a:bodyPr>
-          <a:lstStyle/>
-          <a:p>
-            <a:pPr algn="l">
-              <a:lnSpc>
-                <a:spcPts val="1416"/>
-              </a:lnSpc>
-              <a:spcAft>
-                <a:spcPts val="800"/>
-              </a:spcAft>
-            </a:pPr>
-            <a:r>
-              <a:rPr sz="1200" b="0">
-                <a:solidFill>
-                  <a:srgbClr val="276452"/>
-                </a:solidFill>
-                <a:latin typeface="Liberation Sans"/>
-                <a:hlinkClick r:id="rId8"/>
               </a:rPr>
               <a:t>Open source</a:t>
             </a:r>
@@ -10775,7 +10647,7 @@
                 </a:solidFill>
                 <a:latin typeface="Liberation Sans"/>
               </a:rPr>
-              <a:t>Sources: [1], [2], [6]</a:t>
+              <a:t>Sources: [1], [5]</a:t>
             </a:r>
           </a:p>
         </p:txBody>
@@ -11558,7 +11430,7 @@
                 </a:solidFill>
                 <a:latin typeface="Liberation Sans"/>
               </a:rPr>
-              <a:t>Sources: [6], [7]</a:t>
+              <a:t>Sources: [5], [6]</a:t>
             </a:r>
           </a:p>
         </p:txBody>
@@ -12464,7 +12336,7 @@
                 </a:solidFill>
                 <a:latin typeface="Liberation Sans"/>
               </a:rPr>
-              <a:t>Sources: [1], [2], [3]</a:t>
+              <a:t>Sources: [1], [2]</a:t>
             </a:r>
           </a:p>
         </p:txBody>
@@ -13638,7 +13510,7 @@
                 </a:solidFill>
                 <a:latin typeface="Liberation Sans"/>
               </a:rPr>
-              <a:t>Sources: [3], [4]</a:t>
+              <a:t>Sources: [2], [3]</a:t>
             </a:r>
           </a:p>
         </p:txBody>
@@ -14978,7 +14850,7 @@
                 </a:solidFill>
                 <a:latin typeface="Liberation Sans"/>
               </a:rPr>
-              <a:t>Sources: [1], [2], [4], [5]</a:t>
+              <a:t>Sources: [1], [3], [4]</a:t>
             </a:r>
           </a:p>
         </p:txBody>
@@ -16204,7 +16076,7 @@
                 </a:solidFill>
                 <a:latin typeface="Liberation Sans"/>
               </a:rPr>
-              <a:t>c. Research paper 1</a:t>
+              <a:t>c. Research paper</a:t>
             </a:r>
           </a:p>
         </p:txBody>
@@ -16246,7 +16118,7 @@
                 </a:solidFill>
                 <a:latin typeface="Liberation Sans"/>
               </a:rPr>
-              <a:t>Karavani and colleagues • Cell</a:t>
+              <a:t>Lencz and colleagues • eLife</a:t>
             </a:r>
           </a:p>
         </p:txBody>
@@ -16420,8 +16292,8 @@
         </p:nvSpPr>
         <p:spPr>
           <a:xfrm>
-            <a:off x="694944" y="1298448"/>
-            <a:ext cx="10835640" cy="676656"/>
+            <a:off x="694944" y="1280160"/>
+            <a:ext cx="10844784" cy="768096"/>
           </a:xfrm>
           <a:prstGeom prst="rect">
             <a:avLst/>
@@ -16436,20 +16308,20 @@
           <a:p>
             <a:pPr algn="l">
               <a:lnSpc>
-                <a:spcPts val="2713"/>
-              </a:lnSpc>
-              <a:spcAft>
-                <a:spcPts val="800"/>
-              </a:spcAft>
-            </a:pPr>
-            <a:r>
-              <a:rPr sz="2300" b="1">
+                <a:spcPts val="2595"/>
+              </a:lnSpc>
+              <a:spcAft>
+                <a:spcPts val="800"/>
+              </a:spcAft>
+            </a:pPr>
+            <a:r>
+              <a:rPr sz="2200" b="1">
                 <a:solidFill>
                   <a:srgbClr val="276452"/>
                 </a:solidFill>
                 <a:latin typeface="Liberation Sans"/>
               </a:rPr>
-              <a:t>“Screening human embryos for polygenic traits has limited utility”</a:t>
+              <a:t>“Utility of polygenic embryo screening for disease depends on the selection strategy”</a:t>
             </a:r>
           </a:p>
         </p:txBody>
@@ -16462,8 +16334,8 @@
         </p:nvSpPr>
         <p:spPr>
           <a:xfrm>
-            <a:off x="658368" y="2240280"/>
-            <a:ext cx="5367528" cy="1499616"/>
+            <a:off x="658368" y="2267712"/>
+            <a:ext cx="5367528" cy="1645920"/>
           </a:xfrm>
           <a:prstGeom prst="rect">
             <a:avLst/>
@@ -16505,7 +16377,7 @@
         </p:nvSpPr>
         <p:spPr>
           <a:xfrm>
-            <a:off x="859536" y="2404872"/>
+            <a:off x="859536" y="2432304"/>
             <a:ext cx="4965192" cy="402336"/>
           </a:xfrm>
           <a:prstGeom prst="rect">
@@ -16547,8 +16419,8 @@
         </p:nvSpPr>
         <p:spPr>
           <a:xfrm>
-            <a:off x="859536" y="2843784"/>
-            <a:ext cx="4965192" cy="740664"/>
+            <a:off x="859536" y="2871216"/>
+            <a:ext cx="4965192" cy="886968"/>
           </a:xfrm>
           <a:prstGeom prst="rect">
             <a:avLst/>
@@ -16576,7 +16448,7 @@
                 </a:solidFill>
                 <a:latin typeface="Liberation Sans"/>
               </a:rPr>
-              <a:t>Can selecting embryos using polygenic scores reliably improve traits such as height?</a:t>
+              <a:t>Find out how the embryo selection strategy changes the predicted risk of a complex disease.</a:t>
             </a:r>
           </a:p>
         </p:txBody>
@@ -16589,8 +16461,8 @@
         </p:nvSpPr>
         <p:spPr>
           <a:xfrm>
-            <a:off x="6190488" y="2240280"/>
-            <a:ext cx="5367528" cy="1499616"/>
+            <a:off x="6190488" y="2267712"/>
+            <a:ext cx="5367528" cy="1645920"/>
           </a:xfrm>
           <a:prstGeom prst="rect">
             <a:avLst/>
@@ -16632,7 +16504,7 @@
         </p:nvSpPr>
         <p:spPr>
           <a:xfrm>
-            <a:off x="6391655" y="2404872"/>
+            <a:off x="6391655" y="2432304"/>
             <a:ext cx="4965192" cy="402336"/>
           </a:xfrm>
           <a:prstGeom prst="rect">
@@ -16674,8 +16546,8 @@
         </p:nvSpPr>
         <p:spPr>
           <a:xfrm>
-            <a:off x="6391655" y="2843784"/>
-            <a:ext cx="4965192" cy="740664"/>
+            <a:off x="6391655" y="2871216"/>
+            <a:ext cx="4965192" cy="886968"/>
           </a:xfrm>
           <a:prstGeom prst="rect">
             <a:avLst/>
@@ -16703,7 +16575,7 @@
                 </a:solidFill>
                 <a:latin typeface="Liberation Sans"/>
               </a:rPr>
-              <a:t>Statistical models were compared with genetic and family data.</a:t>
+              <a:t>Used statistical models and simulated offspring based on real genetic data.</a:t>
             </a:r>
           </a:p>
         </p:txBody>
@@ -16716,8 +16588,8 @@
         </p:nvSpPr>
         <p:spPr>
           <a:xfrm>
-            <a:off x="658368" y="3904487"/>
-            <a:ext cx="5367528" cy="1600200"/>
+            <a:off x="658368" y="4087368"/>
+            <a:ext cx="5367528" cy="1609344"/>
           </a:xfrm>
           <a:prstGeom prst="rect">
             <a:avLst/>
@@ -16759,7 +16631,7 @@
         </p:nvSpPr>
         <p:spPr>
           <a:xfrm>
-            <a:off x="859536" y="4069079"/>
+            <a:off x="859536" y="4251959"/>
             <a:ext cx="4965192" cy="402336"/>
           </a:xfrm>
           <a:prstGeom prst="rect">
@@ -16788,7 +16660,7 @@
                 </a:solidFill>
                 <a:latin typeface="Liberation Sans"/>
               </a:rPr>
-              <a:t>Main finding</a:t>
+              <a:t>Data used</a:t>
             </a:r>
           </a:p>
         </p:txBody>
@@ -16801,8 +16673,8 @@
         </p:nvSpPr>
         <p:spPr>
           <a:xfrm>
-            <a:off x="859536" y="4507992"/>
-            <a:ext cx="4965192" cy="841248"/>
+            <a:off x="859536" y="4690872"/>
+            <a:ext cx="4965192" cy="850392"/>
           </a:xfrm>
           <a:prstGeom prst="rect">
             <a:avLst/>
@@ -16830,7 +16702,7 @@
                 </a:solidFill>
                 <a:latin typeface="Liberation Sans"/>
               </a:rPr>
-              <a:t>Predicted gains were limited and uncertain. The top-scoring embryo was not guaranteed the top outcome.</a:t>
+              <a:t>Used genetic data from schizophrenia and Crohn’s disease studies to check the model.</a:t>
             </a:r>
           </a:p>
         </p:txBody>
@@ -16843,8 +16715,8 @@
         </p:nvSpPr>
         <p:spPr>
           <a:xfrm>
-            <a:off x="6190488" y="3904487"/>
-            <a:ext cx="5367528" cy="1600200"/>
+            <a:off x="6190488" y="4087368"/>
+            <a:ext cx="5367528" cy="1609344"/>
           </a:xfrm>
           <a:prstGeom prst="rect">
             <a:avLst/>
@@ -16886,7 +16758,7 @@
         </p:nvSpPr>
         <p:spPr>
           <a:xfrm>
-            <a:off x="6391655" y="4069079"/>
+            <a:off x="6391655" y="4251959"/>
             <a:ext cx="4965192" cy="402336"/>
           </a:xfrm>
           <a:prstGeom prst="rect">
@@ -16915,7 +16787,7 @@
                 </a:solidFill>
                 <a:latin typeface="Liberation Sans"/>
               </a:rPr>
-              <a:t>Limitations</a:t>
+              <a:t>What was compared?</a:t>
             </a:r>
           </a:p>
         </p:txBody>
@@ -16928,8 +16800,8 @@
         </p:nvSpPr>
         <p:spPr>
           <a:xfrm>
-            <a:off x="6391655" y="4507992"/>
-            <a:ext cx="4965192" cy="841248"/>
+            <a:off x="6391655" y="4690872"/>
+            <a:ext cx="4965192" cy="850392"/>
           </a:xfrm>
           <a:prstGeom prst="rect">
             <a:avLst/>
@@ -16957,7 +16829,7 @@
                 </a:solidFill>
                 <a:latin typeface="Liberation Sans"/>
               </a:rPr>
-              <a:t>Results depend on score accuracy, available embryos, and the trait. A score cannot predict a whole life.</a:t>
+              <a:t>Excluding very high-risk embryos versus choosing the embryo with the lowest risk score.</a:t>
             </a:r>
           </a:p>
         </p:txBody>
@@ -16970,8 +16842,8 @@
         </p:nvSpPr>
         <p:spPr>
           <a:xfrm>
-            <a:off x="768096" y="5843016"/>
-            <a:ext cx="10607040" cy="347472"/>
+            <a:off x="777240" y="5916168"/>
+            <a:ext cx="10698480" cy="274320"/>
           </a:xfrm>
           <a:prstGeom prst="rect">
             <a:avLst/>
@@ -16986,20 +16858,20 @@
           <a:p>
             <a:pPr algn="l">
               <a:lnSpc>
-                <a:spcPts val="2242"/>
-              </a:lnSpc>
-              <a:spcAft>
-                <a:spcPts val="800"/>
-              </a:spcAft>
-            </a:pPr>
-            <a:r>
-              <a:rPr sz="1900" b="1">
-                <a:solidFill>
-                  <a:srgbClr val="276452"/>
-                </a:solidFill>
-                <a:latin typeface="Liberation Sans"/>
-              </a:rPr>
-              <a:t>Take-home point: A higher genetic score does not guarantee a “better” child.</a:t>
+                <a:spcPts val="2065"/>
+              </a:lnSpc>
+              <a:spcAft>
+                <a:spcPts val="800"/>
+              </a:spcAft>
+            </a:pPr>
+            <a:r>
+              <a:rPr sz="1750" b="0">
+                <a:solidFill>
+                  <a:srgbClr val="52635D"/>
+                </a:solidFill>
+                <a:latin typeface="Liberation Sans"/>
+              </a:rPr>
+              <a:t>A polygenic score uses many gene variants to estimate disease risk.</a:t>
             </a:r>
           </a:p>
         </p:txBody>
@@ -17110,7 +16982,7 @@
                 </a:solidFill>
                 <a:latin typeface="Liberation Sans"/>
               </a:rPr>
-              <a:t>c. Research paper 2</a:t>
+              <a:t>c. Findings of the research paper</a:t>
             </a:r>
           </a:p>
         </p:txBody>
@@ -17152,7 +17024,7 @@
                 </a:solidFill>
                 <a:latin typeface="Liberation Sans"/>
               </a:rPr>
-              <a:t>Lencz and colleagues • eLife</a:t>
+              <a:t>The selection strategy changed the predicted benefit</a:t>
             </a:r>
           </a:p>
         </p:txBody>
@@ -17271,7 +17143,7 @@
                 </a:solidFill>
                 <a:latin typeface="Liberation Sans"/>
               </a:rPr>
-              <a:t>Sources: [2]</a:t>
+              <a:t>Sources: [1]</a:t>
             </a:r>
           </a:p>
         </p:txBody>
@@ -17320,56 +17192,14 @@
       </p:sp>
       <p:sp>
         <p:nvSpPr>
-          <p:cNvPr id="9" name="TextBox 8"/>
-          <p:cNvSpPr txBox="1"/>
-          <p:nvPr/>
-        </p:nvSpPr>
-        <p:spPr>
-          <a:xfrm>
-            <a:off x="694944" y="1280160"/>
-            <a:ext cx="10844784" cy="768096"/>
-          </a:xfrm>
-          <a:prstGeom prst="rect">
-            <a:avLst/>
-          </a:prstGeom>
-          <a:noFill/>
-        </p:spPr>
-        <p:txBody>
-          <a:bodyPr wrap="square" lIns="0" rIns="0" tIns="0" bIns="0" anchor="t">
-            <a:spAutoFit/>
-          </a:bodyPr>
-          <a:lstStyle/>
-          <a:p>
-            <a:pPr algn="l">
-              <a:lnSpc>
-                <a:spcPts val="2595"/>
-              </a:lnSpc>
-              <a:spcAft>
-                <a:spcPts val="800"/>
-              </a:spcAft>
-            </a:pPr>
-            <a:r>
-              <a:rPr sz="2200" b="1">
-                <a:solidFill>
-                  <a:srgbClr val="276452"/>
-                </a:solidFill>
-                <a:latin typeface="Liberation Sans"/>
-              </a:rPr>
-              <a:t>“Utility of polygenic embryo screening for disease depends on the selection strategy”</a:t>
-            </a:r>
-          </a:p>
-        </p:txBody>
-      </p:sp>
-      <p:sp>
-        <p:nvSpPr>
-          <p:cNvPr id="10" name="Rectangle 9"/>
+          <p:cNvPr id="9" name="Rectangle 8"/>
           <p:cNvSpPr/>
           <p:nvPr/>
         </p:nvSpPr>
         <p:spPr>
           <a:xfrm>
-            <a:off x="658368" y="2267712"/>
-            <a:ext cx="5367528" cy="1645920"/>
+            <a:off x="658368" y="1508760"/>
+            <a:ext cx="5367528" cy="2395728"/>
           </a:xfrm>
           <a:prstGeom prst="rect">
             <a:avLst/>
@@ -17405,14 +17235,56 @@
       </p:sp>
       <p:sp>
         <p:nvSpPr>
+          <p:cNvPr id="10" name="TextBox 9"/>
+          <p:cNvSpPr txBox="1"/>
+          <p:nvPr/>
+        </p:nvSpPr>
+        <p:spPr>
+          <a:xfrm>
+            <a:off x="859536" y="1673351"/>
+            <a:ext cx="4965192" cy="402336"/>
+          </a:xfrm>
+          <a:prstGeom prst="rect">
+            <a:avLst/>
+          </a:prstGeom>
+          <a:noFill/>
+        </p:spPr>
+        <p:txBody>
+          <a:bodyPr wrap="square" lIns="0" rIns="0" tIns="0" bIns="0" anchor="t">
+            <a:spAutoFit/>
+          </a:bodyPr>
+          <a:lstStyle/>
+          <a:p>
+            <a:pPr algn="l">
+              <a:lnSpc>
+                <a:spcPts val="2360"/>
+              </a:lnSpc>
+              <a:spcAft>
+                <a:spcPts val="800"/>
+              </a:spcAft>
+            </a:pPr>
+            <a:r>
+              <a:rPr sz="2000" b="1">
+                <a:solidFill>
+                  <a:srgbClr val="276452"/>
+                </a:solidFill>
+                <a:latin typeface="Liberation Sans"/>
+              </a:rPr>
+              <a:t>Exclude very high-risk embryos</a:t>
+            </a:r>
+          </a:p>
+        </p:txBody>
+      </p:sp>
+      <p:sp>
+        <p:nvSpPr>
           <p:cNvPr id="11" name="TextBox 10"/>
           <p:cNvSpPr txBox="1"/>
           <p:nvPr/>
         </p:nvSpPr>
         <p:spPr>
           <a:xfrm>
-            <a:off x="859536" y="2432304"/>
-            <a:ext cx="4965192" cy="402336"/>
+            <a:off x="859536" y="2112264"/>
+            <a:ext cx="4965192" cy="1636776"/>
           </a:xfrm>
           <a:prstGeom prst="rect">
             <a:avLst/>
@@ -17427,76 +17299,34 @@
           <a:p>
             <a:pPr algn="l">
               <a:lnSpc>
-                <a:spcPts val="2360"/>
-              </a:lnSpc>
-              <a:spcAft>
-                <a:spcPts val="800"/>
-              </a:spcAft>
-            </a:pPr>
-            <a:r>
-              <a:rPr sz="2000" b="1">
-                <a:solidFill>
-                  <a:srgbClr val="276452"/>
-                </a:solidFill>
-                <a:latin typeface="Liberation Sans"/>
-              </a:rPr>
-              <a:t>Aim and method</a:t>
-            </a:r>
-          </a:p>
-        </p:txBody>
-      </p:sp>
-      <p:sp>
-        <p:nvSpPr>
-          <p:cNvPr id="12" name="TextBox 11"/>
-          <p:cNvSpPr txBox="1"/>
-          <p:nvPr/>
-        </p:nvSpPr>
-        <p:spPr>
-          <a:xfrm>
-            <a:off x="859536" y="2871216"/>
-            <a:ext cx="4965192" cy="886968"/>
-          </a:xfrm>
-          <a:prstGeom prst="rect">
-            <a:avLst/>
-          </a:prstGeom>
-          <a:noFill/>
-        </p:spPr>
-        <p:txBody>
-          <a:bodyPr wrap="square" lIns="0" rIns="0" tIns="0" bIns="0" anchor="t">
-            <a:spAutoFit/>
-          </a:bodyPr>
-          <a:lstStyle/>
-          <a:p>
-            <a:pPr algn="l">
-              <a:lnSpc>
-                <a:spcPts val="2124"/>
-              </a:lnSpc>
-              <a:spcAft>
-                <a:spcPts val="800"/>
-              </a:spcAft>
-            </a:pPr>
-            <a:r>
-              <a:rPr sz="1800" b="0">
+                <a:spcPts val="2477"/>
+              </a:lnSpc>
+              <a:spcAft>
+                <a:spcPts val="800"/>
+              </a:spcAft>
+            </a:pPr>
+            <a:r>
+              <a:rPr sz="2100" b="0">
                 <a:solidFill>
                   <a:srgbClr val="24312E"/>
                 </a:solidFill>
                 <a:latin typeface="Liberation Sans"/>
               </a:rPr>
-              <a:t>The study modelled disease risk and checked its predictions using virtual offspring based on real genetic data.</a:t>
-            </a:r>
-          </a:p>
-        </p:txBody>
-      </p:sp>
-      <p:sp>
-        <p:nvSpPr>
-          <p:cNvPr id="13" name="Rectangle 12"/>
+              <a:t>Removing only embryos with very high scores gave relatively small predicted risk reductions.</a:t>
+            </a:r>
+          </a:p>
+        </p:txBody>
+      </p:sp>
+      <p:sp>
+        <p:nvSpPr>
+          <p:cNvPr id="12" name="Rectangle 11"/>
           <p:cNvSpPr/>
           <p:nvPr/>
         </p:nvSpPr>
         <p:spPr>
           <a:xfrm>
-            <a:off x="6190488" y="2267712"/>
-            <a:ext cx="5367528" cy="1645920"/>
+            <a:off x="6190488" y="1508760"/>
+            <a:ext cx="5367528" cy="2395728"/>
           </a:xfrm>
           <a:prstGeom prst="rect">
             <a:avLst/>
@@ -17532,14 +17362,56 @@
       </p:sp>
       <p:sp>
         <p:nvSpPr>
+          <p:cNvPr id="13" name="TextBox 12"/>
+          <p:cNvSpPr txBox="1"/>
+          <p:nvPr/>
+        </p:nvSpPr>
+        <p:spPr>
+          <a:xfrm>
+            <a:off x="6391655" y="1673351"/>
+            <a:ext cx="4965192" cy="402336"/>
+          </a:xfrm>
+          <a:prstGeom prst="rect">
+            <a:avLst/>
+          </a:prstGeom>
+          <a:noFill/>
+        </p:spPr>
+        <p:txBody>
+          <a:bodyPr wrap="square" lIns="0" rIns="0" tIns="0" bIns="0" anchor="t">
+            <a:spAutoFit/>
+          </a:bodyPr>
+          <a:lstStyle/>
+          <a:p>
+            <a:pPr algn="l">
+              <a:lnSpc>
+                <a:spcPts val="2360"/>
+              </a:lnSpc>
+              <a:spcAft>
+                <a:spcPts val="800"/>
+              </a:spcAft>
+            </a:pPr>
+            <a:r>
+              <a:rPr sz="2000" b="1">
+                <a:solidFill>
+                  <a:srgbClr val="276452"/>
+                </a:solidFill>
+                <a:latin typeface="Liberation Sans"/>
+              </a:rPr>
+              <a:t>Choose the lowest-risk embryo</a:t>
+            </a:r>
+          </a:p>
+        </p:txBody>
+      </p:sp>
+      <p:sp>
+        <p:nvSpPr>
           <p:cNvPr id="14" name="TextBox 13"/>
           <p:cNvSpPr txBox="1"/>
           <p:nvPr/>
         </p:nvSpPr>
         <p:spPr>
           <a:xfrm>
-            <a:off x="6391655" y="2432304"/>
-            <a:ext cx="4965192" cy="402336"/>
+            <a:off x="6391655" y="2112264"/>
+            <a:ext cx="4965192" cy="1636776"/>
           </a:xfrm>
           <a:prstGeom prst="rect">
             <a:avLst/>
@@ -17554,34 +17426,76 @@
           <a:p>
             <a:pPr algn="l">
               <a:lnSpc>
-                <a:spcPts val="2360"/>
-              </a:lnSpc>
-              <a:spcAft>
-                <a:spcPts val="800"/>
-              </a:spcAft>
-            </a:pPr>
-            <a:r>
-              <a:rPr sz="2000" b="1">
+                <a:spcPts val="2477"/>
+              </a:lnSpc>
+              <a:spcAft>
+                <a:spcPts val="800"/>
+              </a:spcAft>
+            </a:pPr>
+            <a:r>
+              <a:rPr sz="2100" b="0">
+                <a:solidFill>
+                  <a:srgbClr val="24312E"/>
+                </a:solidFill>
+                <a:latin typeface="Liberation Sans"/>
+              </a:rPr>
+              <a:t>Choosing the lowest-score embryo could give much larger relative risk reductions, if enough viable embryos were available.</a:t>
+            </a:r>
+          </a:p>
+        </p:txBody>
+      </p:sp>
+      <p:sp>
+        <p:nvSpPr>
+          <p:cNvPr id="15" name="TextBox 14"/>
+          <p:cNvSpPr txBox="1"/>
+          <p:nvPr/>
+        </p:nvSpPr>
+        <p:spPr>
+          <a:xfrm>
+            <a:off x="749808" y="4297680"/>
+            <a:ext cx="10698480" cy="365760"/>
+          </a:xfrm>
+          <a:prstGeom prst="rect">
+            <a:avLst/>
+          </a:prstGeom>
+          <a:noFill/>
+        </p:spPr>
+        <p:txBody>
+          <a:bodyPr wrap="square" lIns="0" rIns="0" tIns="0" bIns="0" anchor="t">
+            <a:spAutoFit/>
+          </a:bodyPr>
+          <a:lstStyle/>
+          <a:p>
+            <a:pPr algn="l">
+              <a:lnSpc>
+                <a:spcPts val="2713"/>
+              </a:lnSpc>
+              <a:spcAft>
+                <a:spcPts val="800"/>
+              </a:spcAft>
+            </a:pPr>
+            <a:r>
+              <a:rPr sz="2300" b="1">
                 <a:solidFill>
                   <a:srgbClr val="276452"/>
                 </a:solidFill>
                 <a:latin typeface="Liberation Sans"/>
               </a:rPr>
-              <a:t>Two strategies</a:t>
-            </a:r>
-          </a:p>
-        </p:txBody>
-      </p:sp>
-      <p:sp>
-        <p:nvSpPr>
-          <p:cNvPr id="15" name="TextBox 14"/>
-          <p:cNvSpPr txBox="1"/>
-          <p:nvPr/>
-        </p:nvSpPr>
-        <p:spPr>
-          <a:xfrm>
-            <a:off x="6391655" y="2871216"/>
-            <a:ext cx="4965192" cy="886968"/>
+              <a:t>Why did the results vary?</a:t>
+            </a:r>
+          </a:p>
+        </p:txBody>
+      </p:sp>
+      <p:sp>
+        <p:nvSpPr>
+          <p:cNvPr id="16" name="TextBox 15"/>
+          <p:cNvSpPr txBox="1"/>
+          <p:nvPr/>
+        </p:nvSpPr>
+        <p:spPr>
+          <a:xfrm>
+            <a:off x="749808" y="4846320"/>
+            <a:ext cx="10698480" cy="685800"/>
           </a:xfrm>
           <a:prstGeom prst="rect">
             <a:avLst/>
@@ -17596,35 +17510,34 @@
           <a:p>
             <a:pPr algn="l">
               <a:lnSpc>
-                <a:spcPts val="2124"/>
-              </a:lnSpc>
-              <a:spcAft>
-                <a:spcPts val="800"/>
-              </a:spcAft>
-            </a:pPr>
-            <a:r>
-              <a:rPr sz="1800" b="0">
+                <a:spcPts val="2477"/>
+              </a:lnSpc>
+              <a:spcAft>
+                <a:spcPts val="800"/>
+              </a:spcAft>
+            </a:pPr>
+            <a:r>
+              <a:rPr sz="2100" b="0">
                 <a:solidFill>
                   <a:srgbClr val="24312E"/>
                 </a:solidFill>
                 <a:latin typeface="Liberation Sans"/>
               </a:rPr>
-              <a:t>1. Exclude only very high-risk embryos.
-2. Prioritize the embryo with the lowest score.</a:t>
-            </a:r>
-          </a:p>
-        </p:txBody>
-      </p:sp>
-      <p:sp>
-        <p:nvSpPr>
-          <p:cNvPr id="16" name="Rectangle 15"/>
+              <a:t>The benefit changed with score accuracy, embryo number, disease frequency, and the parents’ genetic risks.</a:t>
+            </a:r>
+          </a:p>
+        </p:txBody>
+      </p:sp>
+      <p:sp>
+        <p:nvSpPr>
+          <p:cNvPr id="17" name="Rectangle 16"/>
           <p:cNvSpPr/>
           <p:nvPr/>
         </p:nvSpPr>
         <p:spPr>
           <a:xfrm>
-            <a:off x="658368" y="4087368"/>
-            <a:ext cx="5367528" cy="1609344"/>
+            <a:off x="594360" y="5687568"/>
+            <a:ext cx="11000232" cy="585216"/>
           </a:xfrm>
           <a:prstGeom prst="rect">
             <a:avLst/>
@@ -17660,14 +17573,14 @@
       </p:sp>
       <p:sp>
         <p:nvSpPr>
-          <p:cNvPr id="17" name="TextBox 16"/>
-          <p:cNvSpPr txBox="1"/>
-          <p:nvPr/>
-        </p:nvSpPr>
-        <p:spPr>
-          <a:xfrm>
-            <a:off x="859536" y="4251959"/>
-            <a:ext cx="4965192" cy="402336"/>
+          <p:cNvPr id="18" name="TextBox 17"/>
+          <p:cNvSpPr txBox="1"/>
+          <p:nvPr/>
+        </p:nvSpPr>
+        <p:spPr>
+          <a:xfrm>
+            <a:off x="786384" y="5806440"/>
+            <a:ext cx="10607040" cy="365760"/>
           </a:xfrm>
           <a:prstGeom prst="rect">
             <a:avLst/>
@@ -17682,231 +17595,20 @@
           <a:p>
             <a:pPr algn="l">
               <a:lnSpc>
-                <a:spcPts val="2360"/>
-              </a:lnSpc>
-              <a:spcAft>
-                <a:spcPts val="800"/>
-              </a:spcAft>
-            </a:pPr>
-            <a:r>
-              <a:rPr sz="2000" b="1">
+                <a:spcPts val="2242"/>
+              </a:lnSpc>
+              <a:spcAft>
+                <a:spcPts val="800"/>
+              </a:spcAft>
+            </a:pPr>
+            <a:r>
+              <a:rPr sz="1900" b="1">
                 <a:solidFill>
                   <a:srgbClr val="276452"/>
                 </a:solidFill>
                 <a:latin typeface="Liberation Sans"/>
               </a:rPr>
-              <a:t>Main finding</a:t>
-            </a:r>
-          </a:p>
-        </p:txBody>
-      </p:sp>
-      <p:sp>
-        <p:nvSpPr>
-          <p:cNvPr id="18" name="TextBox 17"/>
-          <p:cNvSpPr txBox="1"/>
-          <p:nvPr/>
-        </p:nvSpPr>
-        <p:spPr>
-          <a:xfrm>
-            <a:off x="859536" y="4690872"/>
-            <a:ext cx="4965192" cy="850392"/>
-          </a:xfrm>
-          <a:prstGeom prst="rect">
-            <a:avLst/>
-          </a:prstGeom>
-          <a:noFill/>
-        </p:spPr>
-        <p:txBody>
-          <a:bodyPr wrap="square" lIns="0" rIns="0" tIns="0" bIns="0" anchor="t">
-            <a:spAutoFit/>
-          </a:bodyPr>
-          <a:lstStyle/>
-          <a:p>
-            <a:pPr algn="l">
-              <a:lnSpc>
-                <a:spcPts val="2124"/>
-              </a:lnSpc>
-              <a:spcAft>
-                <a:spcPts val="800"/>
-              </a:spcAft>
-            </a:pPr>
-            <a:r>
-              <a:rPr sz="1800" b="0">
-                <a:solidFill>
-                  <a:srgbClr val="24312E"/>
-                </a:solidFill>
-                <a:latin typeface="Liberation Sans"/>
-              </a:rPr>
-              <a:t>Choosing the lowest-risk embryo could give larger relative risk reductions when enough viable embryos were available.</a:t>
-            </a:r>
-          </a:p>
-        </p:txBody>
-      </p:sp>
-      <p:sp>
-        <p:nvSpPr>
-          <p:cNvPr id="19" name="Rectangle 18"/>
-          <p:cNvSpPr/>
-          <p:nvPr/>
-        </p:nvSpPr>
-        <p:spPr>
-          <a:xfrm>
-            <a:off x="6190488" y="4087368"/>
-            <a:ext cx="5367528" cy="1609344"/>
-          </a:xfrm>
-          <a:prstGeom prst="rect">
-            <a:avLst/>
-          </a:prstGeom>
-          <a:solidFill>
-            <a:srgbClr val="EEF5F1"/>
-          </a:solidFill>
-          <a:ln>
-            <a:noFill/>
-          </a:ln>
-        </p:spPr>
-        <p:style>
-          <a:lnRef idx="1">
-            <a:schemeClr val="accent1"/>
-          </a:lnRef>
-          <a:fillRef idx="3">
-            <a:schemeClr val="accent1"/>
-          </a:fillRef>
-          <a:effectRef idx="0">
-            <a:schemeClr val="accent1"/>
-          </a:effectRef>
-          <a:fontRef idx="minor">
-            <a:schemeClr val="lt1"/>
-          </a:fontRef>
-        </p:style>
-        <p:txBody>
-          <a:bodyPr rtlCol="0" anchor="ctr"/>
-          <a:lstStyle/>
-          <a:p>
-            <a:pPr algn="ctr"/>
-          </a:p>
-        </p:txBody>
-      </p:sp>
-      <p:sp>
-        <p:nvSpPr>
-          <p:cNvPr id="20" name="TextBox 19"/>
-          <p:cNvSpPr txBox="1"/>
-          <p:nvPr/>
-        </p:nvSpPr>
-        <p:spPr>
-          <a:xfrm>
-            <a:off x="6391655" y="4251959"/>
-            <a:ext cx="4965192" cy="402336"/>
-          </a:xfrm>
-          <a:prstGeom prst="rect">
-            <a:avLst/>
-          </a:prstGeom>
-          <a:noFill/>
-        </p:spPr>
-        <p:txBody>
-          <a:bodyPr wrap="square" lIns="0" rIns="0" tIns="0" bIns="0" anchor="t">
-            <a:spAutoFit/>
-          </a:bodyPr>
-          <a:lstStyle/>
-          <a:p>
-            <a:pPr algn="l">
-              <a:lnSpc>
-                <a:spcPts val="2360"/>
-              </a:lnSpc>
-              <a:spcAft>
-                <a:spcPts val="800"/>
-              </a:spcAft>
-            </a:pPr>
-            <a:r>
-              <a:rPr sz="2000" b="1">
-                <a:solidFill>
-                  <a:srgbClr val="276452"/>
-                </a:solidFill>
-                <a:latin typeface="Liberation Sans"/>
-              </a:rPr>
-              <a:t>Limitations</a:t>
-            </a:r>
-          </a:p>
-        </p:txBody>
-      </p:sp>
-      <p:sp>
-        <p:nvSpPr>
-          <p:cNvPr id="21" name="TextBox 20"/>
-          <p:cNvSpPr txBox="1"/>
-          <p:nvPr/>
-        </p:nvSpPr>
-        <p:spPr>
-          <a:xfrm>
-            <a:off x="6391655" y="4690872"/>
-            <a:ext cx="4965192" cy="850392"/>
-          </a:xfrm>
-          <a:prstGeom prst="rect">
-            <a:avLst/>
-          </a:prstGeom>
-          <a:noFill/>
-        </p:spPr>
-        <p:txBody>
-          <a:bodyPr wrap="square" lIns="0" rIns="0" tIns="0" bIns="0" anchor="t">
-            <a:spAutoFit/>
-          </a:bodyPr>
-          <a:lstStyle/>
-          <a:p>
-            <a:pPr algn="l">
-              <a:lnSpc>
-                <a:spcPts val="2124"/>
-              </a:lnSpc>
-              <a:spcAft>
-                <a:spcPts val="800"/>
-              </a:spcAft>
-            </a:pPr>
-            <a:r>
-              <a:rPr sz="1800" b="0">
-                <a:solidFill>
-                  <a:srgbClr val="24312E"/>
-                </a:solidFill>
-                <a:latin typeface="Liberation Sans"/>
-              </a:rPr>
-              <a:t>It was not a long-term clinical trial. Results depend on the model, score accuracy, disease, and embryo number.</a:t>
-            </a:r>
-          </a:p>
-        </p:txBody>
-      </p:sp>
-      <p:sp>
-        <p:nvSpPr>
-          <p:cNvPr id="22" name="TextBox 21"/>
-          <p:cNvSpPr txBox="1"/>
-          <p:nvPr/>
-        </p:nvSpPr>
-        <p:spPr>
-          <a:xfrm>
-            <a:off x="777240" y="5916168"/>
-            <a:ext cx="10698480" cy="274320"/>
-          </a:xfrm>
-          <a:prstGeom prst="rect">
-            <a:avLst/>
-          </a:prstGeom>
-          <a:noFill/>
-        </p:spPr>
-        <p:txBody>
-          <a:bodyPr wrap="square" lIns="0" rIns="0" tIns="0" bIns="0" anchor="t">
-            <a:spAutoFit/>
-          </a:bodyPr>
-          <a:lstStyle/>
-          <a:p>
-            <a:pPr algn="l">
-              <a:lnSpc>
-                <a:spcPts val="2065"/>
-              </a:lnSpc>
-              <a:spcAft>
-                <a:spcPts val="800"/>
-              </a:spcAft>
-            </a:pPr>
-            <a:r>
-              <a:rPr sz="1750" b="0">
-                <a:solidFill>
-                  <a:srgbClr val="52635D"/>
-                </a:solidFill>
-                <a:latin typeface="Liberation Sans"/>
-              </a:rPr>
-              <a:t>The paper studied complex diseases, including schizophrenia and Crohn’s disease.</a:t>
+              <a:t>A relative risk reduction does not mean that the disease risk becomes zero.</a:t>
             </a:r>
           </a:p>
         </p:txBody>
@@ -18017,7 +17719,7 @@
                 </a:solidFill>
                 <a:latin typeface="Liberation Sans"/>
               </a:rPr>
-              <a:t>c. What do the two papers tell us?</a:t>
+              <a:t>c. Limitations and meaning of the paper</a:t>
             </a:r>
           </a:p>
         </p:txBody>
@@ -18059,7 +17761,7 @@
                 </a:solidFill>
                 <a:latin typeface="Liberation Sans"/>
               </a:rPr>
-              <a:t>Compare the findings carefully</a:t>
+              <a:t>What we can and cannot conclude</a:t>
             </a:r>
           </a:p>
         </p:txBody>
@@ -18178,7 +17880,7 @@
                 </a:solidFill>
                 <a:latin typeface="Liberation Sans"/>
               </a:rPr>
-              <a:t>Sources: [1], [2]</a:t>
+              <a:t>Sources: [1]</a:t>
             </a:r>
           </a:p>
         </p:txBody>
@@ -18227,16 +17929,16 @@
       </p:sp>
       <p:sp>
         <p:nvSpPr>
-          <p:cNvPr id="9" name="Rectangle 8"/>
+          <p:cNvPr id="9" name="Oval 8"/>
           <p:cNvSpPr/>
           <p:nvPr/>
         </p:nvSpPr>
         <p:spPr>
           <a:xfrm>
-            <a:off x="658368" y="1417320"/>
-            <a:ext cx="2331720" cy="576072"/>
-          </a:xfrm>
-          <a:prstGeom prst="rect">
+            <a:off x="786384" y="1572768"/>
+            <a:ext cx="77724" cy="77724"/>
+          </a:xfrm>
+          <a:prstGeom prst="ellipse">
             <a:avLst/>
           </a:prstGeom>
           <a:solidFill>
@@ -18276,8 +17978,8 @@
         </p:nvSpPr>
         <p:spPr>
           <a:xfrm>
-            <a:off x="795528" y="1536192"/>
-            <a:ext cx="2057400" cy="374904"/>
+            <a:off x="1014983" y="1481328"/>
+            <a:ext cx="10360152" cy="841248"/>
           </a:xfrm>
           <a:prstGeom prst="rect">
             <a:avLst/>
@@ -18292,36 +17994,36 @@
           <a:p>
             <a:pPr algn="l">
               <a:lnSpc>
-                <a:spcPts val="2124"/>
-              </a:lnSpc>
-              <a:spcAft>
-                <a:spcPts val="800"/>
-              </a:spcAft>
-            </a:pPr>
-            <a:r>
-              <a:rPr sz="1800" b="1">
-                <a:solidFill>
-                  <a:srgbClr val="FFFFFF"/>
-                </a:solidFill>
-                <a:latin typeface="Liberation Sans"/>
-              </a:rPr>
-              <a:t>Question</a:t>
-            </a:r>
-          </a:p>
-        </p:txBody>
-      </p:sp>
-      <p:sp>
-        <p:nvSpPr>
-          <p:cNvPr id="11" name="Rectangle 10"/>
+                <a:spcPts val="2595"/>
+              </a:lnSpc>
+              <a:spcAft>
+                <a:spcPts val="800"/>
+              </a:spcAft>
+            </a:pPr>
+            <a:r>
+              <a:rPr sz="2200" b="0">
+                <a:solidFill>
+                  <a:srgbClr val="24312E"/>
+                </a:solidFill>
+                <a:latin typeface="Liberation Sans"/>
+              </a:rPr>
+              <a:t>This was a modelling study, not a trial following children after embryo screening.</a:t>
+            </a:r>
+          </a:p>
+        </p:txBody>
+      </p:sp>
+      <p:sp>
+        <p:nvSpPr>
+          <p:cNvPr id="11" name="Oval 10"/>
           <p:cNvSpPr/>
           <p:nvPr/>
         </p:nvSpPr>
         <p:spPr>
           <a:xfrm>
-            <a:off x="3017520" y="1417320"/>
-            <a:ext cx="4242816" cy="576072"/>
-          </a:xfrm>
-          <a:prstGeom prst="rect">
+            <a:off x="786384" y="2505456"/>
+            <a:ext cx="77724" cy="77724"/>
+          </a:xfrm>
+          <a:prstGeom prst="ellipse">
             <a:avLst/>
           </a:prstGeom>
           <a:solidFill>
@@ -18361,8 +18063,8 @@
         </p:nvSpPr>
         <p:spPr>
           <a:xfrm>
-            <a:off x="3154679" y="1536192"/>
-            <a:ext cx="3968496" cy="374904"/>
+            <a:off x="1014983" y="2414016"/>
+            <a:ext cx="10360152" cy="841248"/>
           </a:xfrm>
           <a:prstGeom prst="rect">
             <a:avLst/>
@@ -18377,36 +18079,36 @@
           <a:p>
             <a:pPr algn="l">
               <a:lnSpc>
-                <a:spcPts val="2124"/>
-              </a:lnSpc>
-              <a:spcAft>
-                <a:spcPts val="800"/>
-              </a:spcAft>
-            </a:pPr>
-            <a:r>
-              <a:rPr sz="1800" b="1">
-                <a:solidFill>
-                  <a:srgbClr val="FFFFFF"/>
-                </a:solidFill>
-                <a:latin typeface="Liberation Sans"/>
-              </a:rPr>
-              <a:t>Paper 1: traits</a:t>
-            </a:r>
-          </a:p>
-        </p:txBody>
-      </p:sp>
-      <p:sp>
-        <p:nvSpPr>
-          <p:cNvPr id="13" name="Rectangle 12"/>
+                <a:spcPts val="2595"/>
+              </a:lnSpc>
+              <a:spcAft>
+                <a:spcPts val="800"/>
+              </a:spcAft>
+            </a:pPr>
+            <a:r>
+              <a:rPr sz="2200" b="0">
+                <a:solidFill>
+                  <a:srgbClr val="24312E"/>
+                </a:solidFill>
+                <a:latin typeface="Liberation Sans"/>
+              </a:rPr>
+              <a:t>Predictions depended on accurate risk scores and enough viable embryos.</a:t>
+            </a:r>
+          </a:p>
+        </p:txBody>
+      </p:sp>
+      <p:sp>
+        <p:nvSpPr>
+          <p:cNvPr id="13" name="Oval 12"/>
           <p:cNvSpPr/>
           <p:nvPr/>
         </p:nvSpPr>
         <p:spPr>
           <a:xfrm>
-            <a:off x="7296912" y="1417320"/>
-            <a:ext cx="4242816" cy="576072"/>
-          </a:xfrm>
-          <a:prstGeom prst="rect">
+            <a:off x="786384" y="3438144"/>
+            <a:ext cx="77724" cy="77724"/>
+          </a:xfrm>
+          <a:prstGeom prst="ellipse">
             <a:avLst/>
           </a:prstGeom>
           <a:solidFill>
@@ -18446,8 +18148,8 @@
         </p:nvSpPr>
         <p:spPr>
           <a:xfrm>
-            <a:off x="7434072" y="1536192"/>
-            <a:ext cx="3968496" cy="374904"/>
+            <a:off x="1014983" y="3346704"/>
+            <a:ext cx="10360152" cy="841248"/>
           </a:xfrm>
           <a:prstGeom prst="rect">
             <a:avLst/>
@@ -18462,20 +18164,20 @@
           <a:p>
             <a:pPr algn="l">
               <a:lnSpc>
-                <a:spcPts val="2124"/>
-              </a:lnSpc>
-              <a:spcAft>
-                <a:spcPts val="800"/>
-              </a:spcAft>
-            </a:pPr>
-            <a:r>
-              <a:rPr sz="1800" b="1">
-                <a:solidFill>
-                  <a:srgbClr val="FFFFFF"/>
-                </a:solidFill>
-                <a:latin typeface="Liberation Sans"/>
-              </a:rPr>
-              <a:t>Paper 2: disease risk</a:t>
+                <a:spcPts val="2595"/>
+              </a:lnSpc>
+              <a:spcAft>
+                <a:spcPts val="800"/>
+              </a:spcAft>
+            </a:pPr>
+            <a:r>
+              <a:rPr sz="2200" b="0">
+                <a:solidFill>
+                  <a:srgbClr val="24312E"/>
+                </a:solidFill>
+                <a:latin typeface="Liberation Sans"/>
+              </a:rPr>
+              <a:t>The model focused on one disease at a time; results for individual couples could differ.</a:t>
             </a:r>
           </a:p>
         </p:txBody>
@@ -18488,8 +18190,8 @@
         </p:nvSpPr>
         <p:spPr>
           <a:xfrm>
-            <a:off x="658368" y="2048256"/>
-            <a:ext cx="2331720" cy="950976"/>
+            <a:off x="685800" y="4526280"/>
+            <a:ext cx="10808208" cy="1508760"/>
           </a:xfrm>
           <a:prstGeom prst="rect">
             <a:avLst/>
@@ -18531,8 +18233,8 @@
         </p:nvSpPr>
         <p:spPr>
           <a:xfrm>
-            <a:off x="795528" y="2167128"/>
-            <a:ext cx="2057400" cy="749808"/>
+            <a:off x="886968" y="4690872"/>
+            <a:ext cx="10405872" cy="402336"/>
           </a:xfrm>
           <a:prstGeom prst="rect">
             <a:avLst/>
@@ -18547,6 +18249,48 @@
           <a:p>
             <a:pPr algn="l">
               <a:lnSpc>
+                <a:spcPts val="2360"/>
+              </a:lnSpc>
+              <a:spcAft>
+                <a:spcPts val="800"/>
+              </a:spcAft>
+            </a:pPr>
+            <a:r>
+              <a:rPr sz="2000" b="1">
+                <a:solidFill>
+                  <a:srgbClr val="276452"/>
+                </a:solidFill>
+                <a:latin typeface="Liberation Sans"/>
+              </a:rPr>
+              <a:t>What this means for our topic</a:t>
+            </a:r>
+          </a:p>
+        </p:txBody>
+      </p:sp>
+      <p:sp>
+        <p:nvSpPr>
+          <p:cNvPr id="17" name="TextBox 16"/>
+          <p:cNvSpPr txBox="1"/>
+          <p:nvPr/>
+        </p:nvSpPr>
+        <p:spPr>
+          <a:xfrm>
+            <a:off x="886968" y="5129784"/>
+            <a:ext cx="10405872" cy="749808"/>
+          </a:xfrm>
+          <a:prstGeom prst="rect">
+            <a:avLst/>
+          </a:prstGeom>
+          <a:noFill/>
+        </p:spPr>
+        <p:txBody>
+          <a:bodyPr wrap="square" lIns="0" rIns="0" tIns="0" bIns="0" anchor="t">
+            <a:spAutoFit/>
+          </a:bodyPr>
+          <a:lstStyle/>
+          <a:p>
+            <a:pPr algn="l">
+              <a:lnSpc>
                 <a:spcPts val="2124"/>
               </a:lnSpc>
               <a:spcAft>
@@ -18560,771 +18304,7 @@
                 </a:solidFill>
                 <a:latin typeface="Liberation Sans"/>
               </a:rPr>
-              <a:t>Main focus</a:t>
-            </a:r>
-          </a:p>
-        </p:txBody>
-      </p:sp>
-      <p:sp>
-        <p:nvSpPr>
-          <p:cNvPr id="17" name="Rectangle 16"/>
-          <p:cNvSpPr/>
-          <p:nvPr/>
-        </p:nvSpPr>
-        <p:spPr>
-          <a:xfrm>
-            <a:off x="3017520" y="2048256"/>
-            <a:ext cx="4242816" cy="950976"/>
-          </a:xfrm>
-          <a:prstGeom prst="rect">
-            <a:avLst/>
-          </a:prstGeom>
-          <a:solidFill>
-            <a:srgbClr val="EEF5F1"/>
-          </a:solidFill>
-          <a:ln>
-            <a:noFill/>
-          </a:ln>
-        </p:spPr>
-        <p:style>
-          <a:lnRef idx="1">
-            <a:schemeClr val="accent1"/>
-          </a:lnRef>
-          <a:fillRef idx="3">
-            <a:schemeClr val="accent1"/>
-          </a:fillRef>
-          <a:effectRef idx="0">
-            <a:schemeClr val="accent1"/>
-          </a:effectRef>
-          <a:fontRef idx="minor">
-            <a:schemeClr val="lt1"/>
-          </a:fontRef>
-        </p:style>
-        <p:txBody>
-          <a:bodyPr rtlCol="0" anchor="ctr"/>
-          <a:lstStyle/>
-          <a:p>
-            <a:pPr algn="ctr"/>
-          </a:p>
-        </p:txBody>
-      </p:sp>
-      <p:sp>
-        <p:nvSpPr>
-          <p:cNvPr id="18" name="TextBox 17"/>
-          <p:cNvSpPr txBox="1"/>
-          <p:nvPr/>
-        </p:nvSpPr>
-        <p:spPr>
-          <a:xfrm>
-            <a:off x="3154679" y="2167128"/>
-            <a:ext cx="3968496" cy="749808"/>
-          </a:xfrm>
-          <a:prstGeom prst="rect">
-            <a:avLst/>
-          </a:prstGeom>
-          <a:noFill/>
-        </p:spPr>
-        <p:txBody>
-          <a:bodyPr wrap="square" lIns="0" rIns="0" tIns="0" bIns="0" anchor="t">
-            <a:spAutoFit/>
-          </a:bodyPr>
-          <a:lstStyle/>
-          <a:p>
-            <a:pPr algn="l">
-              <a:lnSpc>
-                <a:spcPts val="2124"/>
-              </a:lnSpc>
-              <a:spcAft>
-                <a:spcPts val="800"/>
-              </a:spcAft>
-            </a:pPr>
-            <a:r>
-              <a:rPr sz="1800" b="0">
-                <a:solidFill>
-                  <a:srgbClr val="24312E"/>
-                </a:solidFill>
-                <a:latin typeface="Liberation Sans"/>
-              </a:rPr>
-              <a:t>Predicted changes in traits such as height.</a:t>
-            </a:r>
-          </a:p>
-        </p:txBody>
-      </p:sp>
-      <p:sp>
-        <p:nvSpPr>
-          <p:cNvPr id="19" name="Rectangle 18"/>
-          <p:cNvSpPr/>
-          <p:nvPr/>
-        </p:nvSpPr>
-        <p:spPr>
-          <a:xfrm>
-            <a:off x="7296912" y="2048256"/>
-            <a:ext cx="4242816" cy="950976"/>
-          </a:xfrm>
-          <a:prstGeom prst="rect">
-            <a:avLst/>
-          </a:prstGeom>
-          <a:solidFill>
-            <a:srgbClr val="EEF5F1"/>
-          </a:solidFill>
-          <a:ln>
-            <a:noFill/>
-          </a:ln>
-        </p:spPr>
-        <p:style>
-          <a:lnRef idx="1">
-            <a:schemeClr val="accent1"/>
-          </a:lnRef>
-          <a:fillRef idx="3">
-            <a:schemeClr val="accent1"/>
-          </a:fillRef>
-          <a:effectRef idx="0">
-            <a:schemeClr val="accent1"/>
-          </a:effectRef>
-          <a:fontRef idx="minor">
-            <a:schemeClr val="lt1"/>
-          </a:fontRef>
-        </p:style>
-        <p:txBody>
-          <a:bodyPr rtlCol="0" anchor="ctr"/>
-          <a:lstStyle/>
-          <a:p>
-            <a:pPr algn="ctr"/>
-          </a:p>
-        </p:txBody>
-      </p:sp>
-      <p:sp>
-        <p:nvSpPr>
-          <p:cNvPr id="20" name="TextBox 19"/>
-          <p:cNvSpPr txBox="1"/>
-          <p:nvPr/>
-        </p:nvSpPr>
-        <p:spPr>
-          <a:xfrm>
-            <a:off x="7434072" y="2167128"/>
-            <a:ext cx="3968496" cy="749808"/>
-          </a:xfrm>
-          <a:prstGeom prst="rect">
-            <a:avLst/>
-          </a:prstGeom>
-          <a:noFill/>
-        </p:spPr>
-        <p:txBody>
-          <a:bodyPr wrap="square" lIns="0" rIns="0" tIns="0" bIns="0" anchor="t">
-            <a:spAutoFit/>
-          </a:bodyPr>
-          <a:lstStyle/>
-          <a:p>
-            <a:pPr algn="l">
-              <a:lnSpc>
-                <a:spcPts val="2124"/>
-              </a:lnSpc>
-              <a:spcAft>
-                <a:spcPts val="800"/>
-              </a:spcAft>
-            </a:pPr>
-            <a:r>
-              <a:rPr sz="1800" b="0">
-                <a:solidFill>
-                  <a:srgbClr val="24312E"/>
-                </a:solidFill>
-                <a:latin typeface="Liberation Sans"/>
-              </a:rPr>
-              <a:t>Predicted reduction in one complex disease risk.</a:t>
-            </a:r>
-          </a:p>
-        </p:txBody>
-      </p:sp>
-      <p:sp>
-        <p:nvSpPr>
-          <p:cNvPr id="21" name="Rectangle 20"/>
-          <p:cNvSpPr/>
-          <p:nvPr/>
-        </p:nvSpPr>
-        <p:spPr>
-          <a:xfrm>
-            <a:off x="658368" y="3054096"/>
-            <a:ext cx="2331720" cy="950976"/>
-          </a:xfrm>
-          <a:prstGeom prst="rect">
-            <a:avLst/>
-          </a:prstGeom>
-          <a:solidFill>
-            <a:srgbClr val="FAFBF8"/>
-          </a:solidFill>
-          <a:ln>
-            <a:noFill/>
-          </a:ln>
-        </p:spPr>
-        <p:style>
-          <a:lnRef idx="1">
-            <a:schemeClr val="accent1"/>
-          </a:lnRef>
-          <a:fillRef idx="3">
-            <a:schemeClr val="accent1"/>
-          </a:fillRef>
-          <a:effectRef idx="0">
-            <a:schemeClr val="accent1"/>
-          </a:effectRef>
-          <a:fontRef idx="minor">
-            <a:schemeClr val="lt1"/>
-          </a:fontRef>
-        </p:style>
-        <p:txBody>
-          <a:bodyPr rtlCol="0" anchor="ctr"/>
-          <a:lstStyle/>
-          <a:p>
-            <a:pPr algn="ctr"/>
-          </a:p>
-        </p:txBody>
-      </p:sp>
-      <p:sp>
-        <p:nvSpPr>
-          <p:cNvPr id="22" name="TextBox 21"/>
-          <p:cNvSpPr txBox="1"/>
-          <p:nvPr/>
-        </p:nvSpPr>
-        <p:spPr>
-          <a:xfrm>
-            <a:off x="795528" y="3172968"/>
-            <a:ext cx="2057400" cy="749808"/>
-          </a:xfrm>
-          <a:prstGeom prst="rect">
-            <a:avLst/>
-          </a:prstGeom>
-          <a:noFill/>
-        </p:spPr>
-        <p:txBody>
-          <a:bodyPr wrap="square" lIns="0" rIns="0" tIns="0" bIns="0" anchor="t">
-            <a:spAutoFit/>
-          </a:bodyPr>
-          <a:lstStyle/>
-          <a:p>
-            <a:pPr algn="l">
-              <a:lnSpc>
-                <a:spcPts val="2124"/>
-              </a:lnSpc>
-              <a:spcAft>
-                <a:spcPts val="800"/>
-              </a:spcAft>
-            </a:pPr>
-            <a:r>
-              <a:rPr sz="1800" b="0">
-                <a:solidFill>
-                  <a:srgbClr val="24312E"/>
-                </a:solidFill>
-                <a:latin typeface="Liberation Sans"/>
-              </a:rPr>
-              <a:t>Main message</a:t>
-            </a:r>
-          </a:p>
-        </p:txBody>
-      </p:sp>
-      <p:sp>
-        <p:nvSpPr>
-          <p:cNvPr id="23" name="Rectangle 22"/>
-          <p:cNvSpPr/>
-          <p:nvPr/>
-        </p:nvSpPr>
-        <p:spPr>
-          <a:xfrm>
-            <a:off x="3017520" y="3054096"/>
-            <a:ext cx="4242816" cy="950976"/>
-          </a:xfrm>
-          <a:prstGeom prst="rect">
-            <a:avLst/>
-          </a:prstGeom>
-          <a:solidFill>
-            <a:srgbClr val="FAFBF8"/>
-          </a:solidFill>
-          <a:ln>
-            <a:noFill/>
-          </a:ln>
-        </p:spPr>
-        <p:style>
-          <a:lnRef idx="1">
-            <a:schemeClr val="accent1"/>
-          </a:lnRef>
-          <a:fillRef idx="3">
-            <a:schemeClr val="accent1"/>
-          </a:fillRef>
-          <a:effectRef idx="0">
-            <a:schemeClr val="accent1"/>
-          </a:effectRef>
-          <a:fontRef idx="minor">
-            <a:schemeClr val="lt1"/>
-          </a:fontRef>
-        </p:style>
-        <p:txBody>
-          <a:bodyPr rtlCol="0" anchor="ctr"/>
-          <a:lstStyle/>
-          <a:p>
-            <a:pPr algn="ctr"/>
-          </a:p>
-        </p:txBody>
-      </p:sp>
-      <p:sp>
-        <p:nvSpPr>
-          <p:cNvPr id="24" name="TextBox 23"/>
-          <p:cNvSpPr txBox="1"/>
-          <p:nvPr/>
-        </p:nvSpPr>
-        <p:spPr>
-          <a:xfrm>
-            <a:off x="3154679" y="3172968"/>
-            <a:ext cx="3968496" cy="749808"/>
-          </a:xfrm>
-          <a:prstGeom prst="rect">
-            <a:avLst/>
-          </a:prstGeom>
-          <a:noFill/>
-        </p:spPr>
-        <p:txBody>
-          <a:bodyPr wrap="square" lIns="0" rIns="0" tIns="0" bIns="0" anchor="t">
-            <a:spAutoFit/>
-          </a:bodyPr>
-          <a:lstStyle/>
-          <a:p>
-            <a:pPr algn="l">
-              <a:lnSpc>
-                <a:spcPts val="2124"/>
-              </a:lnSpc>
-              <a:spcAft>
-                <a:spcPts val="800"/>
-              </a:spcAft>
-            </a:pPr>
-            <a:r>
-              <a:rPr sz="1800" b="0">
-                <a:solidFill>
-                  <a:srgbClr val="24312E"/>
-                </a:solidFill>
-                <a:latin typeface="Liberation Sans"/>
-              </a:rPr>
-              <a:t>Gains were limited and uncertain in the studied settings.</a:t>
-            </a:r>
-          </a:p>
-        </p:txBody>
-      </p:sp>
-      <p:sp>
-        <p:nvSpPr>
-          <p:cNvPr id="25" name="Rectangle 24"/>
-          <p:cNvSpPr/>
-          <p:nvPr/>
-        </p:nvSpPr>
-        <p:spPr>
-          <a:xfrm>
-            <a:off x="7296912" y="3054096"/>
-            <a:ext cx="4242816" cy="950976"/>
-          </a:xfrm>
-          <a:prstGeom prst="rect">
-            <a:avLst/>
-          </a:prstGeom>
-          <a:solidFill>
-            <a:srgbClr val="FAFBF8"/>
-          </a:solidFill>
-          <a:ln>
-            <a:noFill/>
-          </a:ln>
-        </p:spPr>
-        <p:style>
-          <a:lnRef idx="1">
-            <a:schemeClr val="accent1"/>
-          </a:lnRef>
-          <a:fillRef idx="3">
-            <a:schemeClr val="accent1"/>
-          </a:fillRef>
-          <a:effectRef idx="0">
-            <a:schemeClr val="accent1"/>
-          </a:effectRef>
-          <a:fontRef idx="minor">
-            <a:schemeClr val="lt1"/>
-          </a:fontRef>
-        </p:style>
-        <p:txBody>
-          <a:bodyPr rtlCol="0" anchor="ctr"/>
-          <a:lstStyle/>
-          <a:p>
-            <a:pPr algn="ctr"/>
-          </a:p>
-        </p:txBody>
-      </p:sp>
-      <p:sp>
-        <p:nvSpPr>
-          <p:cNvPr id="26" name="TextBox 25"/>
-          <p:cNvSpPr txBox="1"/>
-          <p:nvPr/>
-        </p:nvSpPr>
-        <p:spPr>
-          <a:xfrm>
-            <a:off x="7434072" y="3172968"/>
-            <a:ext cx="3968496" cy="749808"/>
-          </a:xfrm>
-          <a:prstGeom prst="rect">
-            <a:avLst/>
-          </a:prstGeom>
-          <a:noFill/>
-        </p:spPr>
-        <p:txBody>
-          <a:bodyPr wrap="square" lIns="0" rIns="0" tIns="0" bIns="0" anchor="t">
-            <a:spAutoFit/>
-          </a:bodyPr>
-          <a:lstStyle/>
-          <a:p>
-            <a:pPr algn="l">
-              <a:lnSpc>
-                <a:spcPts val="2124"/>
-              </a:lnSpc>
-              <a:spcAft>
-                <a:spcPts val="800"/>
-              </a:spcAft>
-            </a:pPr>
-            <a:r>
-              <a:rPr sz="1800" b="0">
-                <a:solidFill>
-                  <a:srgbClr val="24312E"/>
-                </a:solidFill>
-                <a:latin typeface="Liberation Sans"/>
-              </a:rPr>
-              <a:t>The strategy can greatly change the predicted benefit.</a:t>
-            </a:r>
-          </a:p>
-        </p:txBody>
-      </p:sp>
-      <p:sp>
-        <p:nvSpPr>
-          <p:cNvPr id="27" name="Rectangle 26"/>
-          <p:cNvSpPr/>
-          <p:nvPr/>
-        </p:nvSpPr>
-        <p:spPr>
-          <a:xfrm>
-            <a:off x="658368" y="4059936"/>
-            <a:ext cx="2331720" cy="950976"/>
-          </a:xfrm>
-          <a:prstGeom prst="rect">
-            <a:avLst/>
-          </a:prstGeom>
-          <a:solidFill>
-            <a:srgbClr val="EEF5F1"/>
-          </a:solidFill>
-          <a:ln>
-            <a:noFill/>
-          </a:ln>
-        </p:spPr>
-        <p:style>
-          <a:lnRef idx="1">
-            <a:schemeClr val="accent1"/>
-          </a:lnRef>
-          <a:fillRef idx="3">
-            <a:schemeClr val="accent1"/>
-          </a:fillRef>
-          <a:effectRef idx="0">
-            <a:schemeClr val="accent1"/>
-          </a:effectRef>
-          <a:fontRef idx="minor">
-            <a:schemeClr val="lt1"/>
-          </a:fontRef>
-        </p:style>
-        <p:txBody>
-          <a:bodyPr rtlCol="0" anchor="ctr"/>
-          <a:lstStyle/>
-          <a:p>
-            <a:pPr algn="ctr"/>
-          </a:p>
-        </p:txBody>
-      </p:sp>
-      <p:sp>
-        <p:nvSpPr>
-          <p:cNvPr id="28" name="TextBox 27"/>
-          <p:cNvSpPr txBox="1"/>
-          <p:nvPr/>
-        </p:nvSpPr>
-        <p:spPr>
-          <a:xfrm>
-            <a:off x="795528" y="4178808"/>
-            <a:ext cx="2057400" cy="749808"/>
-          </a:xfrm>
-          <a:prstGeom prst="rect">
-            <a:avLst/>
-          </a:prstGeom>
-          <a:noFill/>
-        </p:spPr>
-        <p:txBody>
-          <a:bodyPr wrap="square" lIns="0" rIns="0" tIns="0" bIns="0" anchor="t">
-            <a:spAutoFit/>
-          </a:bodyPr>
-          <a:lstStyle/>
-          <a:p>
-            <a:pPr algn="l">
-              <a:lnSpc>
-                <a:spcPts val="2124"/>
-              </a:lnSpc>
-              <a:spcAft>
-                <a:spcPts val="800"/>
-              </a:spcAft>
-            </a:pPr>
-            <a:r>
-              <a:rPr sz="1800" b="0">
-                <a:solidFill>
-                  <a:srgbClr val="24312E"/>
-                </a:solidFill>
-                <a:latin typeface="Liberation Sans"/>
-              </a:rPr>
-              <a:t>Shared limit</a:t>
-            </a:r>
-          </a:p>
-        </p:txBody>
-      </p:sp>
-      <p:sp>
-        <p:nvSpPr>
-          <p:cNvPr id="29" name="Rectangle 28"/>
-          <p:cNvSpPr/>
-          <p:nvPr/>
-        </p:nvSpPr>
-        <p:spPr>
-          <a:xfrm>
-            <a:off x="3017520" y="4059936"/>
-            <a:ext cx="4242816" cy="950976"/>
-          </a:xfrm>
-          <a:prstGeom prst="rect">
-            <a:avLst/>
-          </a:prstGeom>
-          <a:solidFill>
-            <a:srgbClr val="EEF5F1"/>
-          </a:solidFill>
-          <a:ln>
-            <a:noFill/>
-          </a:ln>
-        </p:spPr>
-        <p:style>
-          <a:lnRef idx="1">
-            <a:schemeClr val="accent1"/>
-          </a:lnRef>
-          <a:fillRef idx="3">
-            <a:schemeClr val="accent1"/>
-          </a:fillRef>
-          <a:effectRef idx="0">
-            <a:schemeClr val="accent1"/>
-          </a:effectRef>
-          <a:fontRef idx="minor">
-            <a:schemeClr val="lt1"/>
-          </a:fontRef>
-        </p:style>
-        <p:txBody>
-          <a:bodyPr rtlCol="0" anchor="ctr"/>
-          <a:lstStyle/>
-          <a:p>
-            <a:pPr algn="ctr"/>
-          </a:p>
-        </p:txBody>
-      </p:sp>
-      <p:sp>
-        <p:nvSpPr>
-          <p:cNvPr id="30" name="TextBox 29"/>
-          <p:cNvSpPr txBox="1"/>
-          <p:nvPr/>
-        </p:nvSpPr>
-        <p:spPr>
-          <a:xfrm>
-            <a:off x="3154679" y="4178808"/>
-            <a:ext cx="3968496" cy="749808"/>
-          </a:xfrm>
-          <a:prstGeom prst="rect">
-            <a:avLst/>
-          </a:prstGeom>
-          <a:noFill/>
-        </p:spPr>
-        <p:txBody>
-          <a:bodyPr wrap="square" lIns="0" rIns="0" tIns="0" bIns="0" anchor="t">
-            <a:spAutoFit/>
-          </a:bodyPr>
-          <a:lstStyle/>
-          <a:p>
-            <a:pPr algn="l">
-              <a:lnSpc>
-                <a:spcPts val="2124"/>
-              </a:lnSpc>
-              <a:spcAft>
-                <a:spcPts val="800"/>
-              </a:spcAft>
-            </a:pPr>
-            <a:r>
-              <a:rPr sz="1800" b="0">
-                <a:solidFill>
-                  <a:srgbClr val="24312E"/>
-                </a:solidFill>
-                <a:latin typeface="Liberation Sans"/>
-              </a:rPr>
-              <a:t>A prediction is not a guarantee for an individual child.</a:t>
-            </a:r>
-          </a:p>
-        </p:txBody>
-      </p:sp>
-      <p:sp>
-        <p:nvSpPr>
-          <p:cNvPr id="31" name="Rectangle 30"/>
-          <p:cNvSpPr/>
-          <p:nvPr/>
-        </p:nvSpPr>
-        <p:spPr>
-          <a:xfrm>
-            <a:off x="7296912" y="4059936"/>
-            <a:ext cx="4242816" cy="950976"/>
-          </a:xfrm>
-          <a:prstGeom prst="rect">
-            <a:avLst/>
-          </a:prstGeom>
-          <a:solidFill>
-            <a:srgbClr val="EEF5F1"/>
-          </a:solidFill>
-          <a:ln>
-            <a:noFill/>
-          </a:ln>
-        </p:spPr>
-        <p:style>
-          <a:lnRef idx="1">
-            <a:schemeClr val="accent1"/>
-          </a:lnRef>
-          <a:fillRef idx="3">
-            <a:schemeClr val="accent1"/>
-          </a:fillRef>
-          <a:effectRef idx="0">
-            <a:schemeClr val="accent1"/>
-          </a:effectRef>
-          <a:fontRef idx="minor">
-            <a:schemeClr val="lt1"/>
-          </a:fontRef>
-        </p:style>
-        <p:txBody>
-          <a:bodyPr rtlCol="0" anchor="ctr"/>
-          <a:lstStyle/>
-          <a:p>
-            <a:pPr algn="ctr"/>
-          </a:p>
-        </p:txBody>
-      </p:sp>
-      <p:sp>
-        <p:nvSpPr>
-          <p:cNvPr id="32" name="TextBox 31"/>
-          <p:cNvSpPr txBox="1"/>
-          <p:nvPr/>
-        </p:nvSpPr>
-        <p:spPr>
-          <a:xfrm>
-            <a:off x="7434072" y="4178808"/>
-            <a:ext cx="3968496" cy="749808"/>
-          </a:xfrm>
-          <a:prstGeom prst="rect">
-            <a:avLst/>
-          </a:prstGeom>
-          <a:noFill/>
-        </p:spPr>
-        <p:txBody>
-          <a:bodyPr wrap="square" lIns="0" rIns="0" tIns="0" bIns="0" anchor="t">
-            <a:spAutoFit/>
-          </a:bodyPr>
-          <a:lstStyle/>
-          <a:p>
-            <a:pPr algn="l">
-              <a:lnSpc>
-                <a:spcPts val="2124"/>
-              </a:lnSpc>
-              <a:spcAft>
-                <a:spcPts val="800"/>
-              </a:spcAft>
-            </a:pPr>
-            <a:r>
-              <a:rPr sz="1800" b="0">
-                <a:solidFill>
-                  <a:srgbClr val="24312E"/>
-                </a:solidFill>
-                <a:latin typeface="Liberation Sans"/>
-              </a:rPr>
-              <a:t>A model is not proof of long-term clinical benefit.</a:t>
-            </a:r>
-          </a:p>
-        </p:txBody>
-      </p:sp>
-      <p:sp>
-        <p:nvSpPr>
-          <p:cNvPr id="33" name="TextBox 32"/>
-          <p:cNvSpPr txBox="1"/>
-          <p:nvPr/>
-        </p:nvSpPr>
-        <p:spPr>
-          <a:xfrm>
-            <a:off x="777240" y="5340096"/>
-            <a:ext cx="10698480" cy="338328"/>
-          </a:xfrm>
-          <a:prstGeom prst="rect">
-            <a:avLst/>
-          </a:prstGeom>
-          <a:noFill/>
-        </p:spPr>
-        <p:txBody>
-          <a:bodyPr wrap="square" lIns="0" rIns="0" tIns="0" bIns="0" anchor="t">
-            <a:spAutoFit/>
-          </a:bodyPr>
-          <a:lstStyle/>
-          <a:p>
-            <a:pPr algn="l">
-              <a:lnSpc>
-                <a:spcPts val="2713"/>
-              </a:lnSpc>
-              <a:spcAft>
-                <a:spcPts val="800"/>
-              </a:spcAft>
-            </a:pPr>
-            <a:r>
-              <a:rPr sz="2300" b="1">
-                <a:solidFill>
-                  <a:srgbClr val="276452"/>
-                </a:solidFill>
-                <a:latin typeface="Liberation Sans"/>
-              </a:rPr>
-              <a:t>Example only: 10% risk → 7% risk</a:t>
-            </a:r>
-          </a:p>
-        </p:txBody>
-      </p:sp>
-      <p:sp>
-        <p:nvSpPr>
-          <p:cNvPr id="34" name="TextBox 33"/>
-          <p:cNvSpPr txBox="1"/>
-          <p:nvPr/>
-        </p:nvSpPr>
-        <p:spPr>
-          <a:xfrm>
-            <a:off x="777240" y="5824728"/>
-            <a:ext cx="10698480" cy="356616"/>
-          </a:xfrm>
-          <a:prstGeom prst="rect">
-            <a:avLst/>
-          </a:prstGeom>
-          <a:noFill/>
-        </p:spPr>
-        <p:txBody>
-          <a:bodyPr wrap="square" lIns="0" rIns="0" tIns="0" bIns="0" anchor="t">
-            <a:spAutoFit/>
-          </a:bodyPr>
-          <a:lstStyle/>
-          <a:p>
-            <a:pPr algn="l">
-              <a:lnSpc>
-                <a:spcPts val="2242"/>
-              </a:lnSpc>
-              <a:spcAft>
-                <a:spcPts val="800"/>
-              </a:spcAft>
-            </a:pPr>
-            <a:r>
-              <a:rPr sz="1900" b="0">
-                <a:solidFill>
-                  <a:srgbClr val="24312E"/>
-                </a:solidFill>
-                <a:latin typeface="Liberation Sans"/>
-              </a:rPr>
-              <a:t>That is 3 percentage points lower, or a 30% relative reduction—not zero risk.</a:t>
+              <a:t>The way embryos are ranked matters. But this paper does not prove that screening guarantees a healthy child or that every use is ethically acceptable.</a:t>
             </a:r>
           </a:p>
         </p:txBody>

</xml_diff>